<commit_message>
Update PowerPoint for song #21 in FUBC - Українські
</commit_message>
<xml_diff>
--- a/fubc-ua/21-Чудову пісню Спас мені дав.pptx
+++ b/fubc-ua/21-Чудову пісню Спас мені дав.pptx
@@ -12,9 +12,10 @@
     <p:sldId id="260" r:id="rId6"/>
     <p:sldId id="261" r:id="rId7"/>
     <p:sldId id="262" r:id="rId8"/>
+    <p:sldId id="263" r:id="rId9"/>
   </p:sldIdLst>
   <p:notesMasterIdLst>
-    <p:notesMasterId r:id="rId9"/>
+    <p:notesMasterId r:id="rId10"/>
   </p:notesMasterIdLst>
   <p:sldSz cx="12192000" cy="6858000"/>
   <p:notesSz cx="6858000" cy="12192000"/>
@@ -772,7 +773,7 @@
           <a:p>
             <a:r>
               <a:rPr lang="en-US" dirty="0"/>
-              <a:t>2 · 1/1</a:t>
+              <a:t>P · 1/1</a:t>
             </a:r>
             <a:endParaRPr lang="en-US" dirty="0"/>
           </a:p>
@@ -860,7 +861,7 @@
           <a:p>
             <a:r>
               <a:rPr lang="en-US" dirty="0"/>
-              <a:t>3 · 1/1</a:t>
+              <a:t>2 · 1/1</a:t>
             </a:r>
             <a:endParaRPr lang="en-US" dirty="0"/>
           </a:p>
@@ -948,7 +949,7 @@
           <a:p>
             <a:r>
               <a:rPr lang="en-US" dirty="0"/>
-              <a:t>P · 1/1</a:t>
+              <a:t>3 · 1/1</a:t>
             </a:r>
             <a:endParaRPr lang="en-US" dirty="0"/>
           </a:p>
@@ -1036,7 +1037,7 @@
           <a:p>
             <a:r>
               <a:rPr lang="en-US" dirty="0"/>
-              <a:t/>
+              <a:t>P · 1/1</a:t>
             </a:r>
             <a:endParaRPr lang="en-US" dirty="0"/>
           </a:p>
@@ -1060,6 +1061,94 @@
             <a:fld id="{F7021451-1387-4CA6-816F-3879F97B5CBC}" type="slidenum">
               <a:rPr lang="en-US"/>
               <a:t>7</a:t>
+            </a:fld>
+            <a:endParaRPr lang="en-US"/>
+          </a:p>
+        </p:txBody>
+      </p:sp>
+    </p:spTree>
+    <p:extLst>
+      <p:ext uri="{BB962C8B-B14F-4D97-AF65-F5344CB8AC3E}">
+        <p14:creationId xmlns:p14="http://schemas.microsoft.com/office/powerpoint/2010/main" val="1024086991"/>
+      </p:ext>
+    </p:extLst>
+  </p:cSld>
+  <p:clrMapOvr>
+    <a:masterClrMapping/>
+  </p:clrMapOvr>
+</p:notes>
+</file>
+
+<file path=ppt/notesSlides/notesSlide8.xml><?xml version="1.0" encoding="utf-8"?>
+<p:notes xmlns:a="http://schemas.openxmlformats.org/drawingml/2006/main" xmlns:r="http://schemas.openxmlformats.org/officeDocument/2006/relationships" xmlns:p="http://schemas.openxmlformats.org/presentationml/2006/main">
+  <p:cSld>
+    <p:spTree>
+      <p:nvGrpSpPr>
+        <p:cNvPr id="1" name=""/>
+        <p:cNvGrpSpPr/>
+        <p:nvPr/>
+      </p:nvGrpSpPr>
+      <p:grpSpPr>
+        <a:xfrm>
+          <a:off x="0" y="0"/>
+          <a:ext cx="0" cy="0"/>
+          <a:chOff x="0" y="0"/>
+          <a:chExt cx="0" cy="0"/>
+        </a:xfrm>
+      </p:grpSpPr>
+      <p:sp>
+        <p:nvSpPr>
+          <p:cNvPr id="2" name="Slide Image Placeholder 1"/>
+          <p:cNvSpPr>
+            <a:spLocks noGrp="1" noRot="1" noChangeAspect="1"/>
+          </p:cNvSpPr>
+          <p:nvPr>
+            <p:ph type="sldImg"/>
+          </p:nvPr>
+        </p:nvSpPr>
+        <p:spPr/>
+      </p:sp>
+      <p:sp>
+        <p:nvSpPr>
+          <p:cNvPr id="3" name="Notes Placeholder 2"/>
+          <p:cNvSpPr>
+            <a:spLocks noGrp="1"/>
+          </p:cNvSpPr>
+          <p:nvPr>
+            <p:ph type="body" idx="1"/>
+          </p:nvPr>
+        </p:nvSpPr>
+        <p:spPr/>
+        <p:txBody>
+          <a:bodyPr/>
+          <a:lstStyle/>
+          <a:p>
+            <a:r>
+              <a:rPr lang="en-US" dirty="0"/>
+              <a:t/>
+            </a:r>
+            <a:endParaRPr lang="en-US" dirty="0"/>
+          </a:p>
+        </p:txBody>
+      </p:sp>
+      <p:sp>
+        <p:nvSpPr>
+          <p:cNvPr id="4" name="Slide Number Placeholder 3"/>
+          <p:cNvSpPr>
+            <a:spLocks noGrp="1"/>
+          </p:cNvSpPr>
+          <p:nvPr>
+            <p:ph type="sldNum" sz="quarter" idx="10"/>
+          </p:nvPr>
+        </p:nvSpPr>
+        <p:spPr/>
+        <p:txBody>
+          <a:bodyPr/>
+          <a:lstStyle/>
+          <a:p>
+            <a:fld id="{F7021451-1387-4CA6-816F-3879F97B5CBC}" type="slidenum">
+              <a:rPr lang="en-US"/>
+              <a:t>8</a:t>
             </a:fld>
             <a:endParaRPr lang="en-US"/>
           </a:p>
@@ -1749,7 +1838,7 @@
               <a:buNone/>
             </a:pPr>
             <a:r>
-              <a:rPr lang="en-US" sz="5100" b="1" dirty="0">
+              <a:rPr lang="en-US" sz="5200" b="1" i="1" dirty="0">
                 <a:solidFill>
                   <a:srgbClr val="FFFFFF"/>
                 </a:solidFill>
@@ -1757,16 +1846,16 @@
                 <a:ea typeface="Arial" pitchFamily="34" charset="-122"/>
                 <a:cs typeface="Arial" pitchFamily="34" charset="-120"/>
               </a:rPr>
-              <a:t>Любов Христа, що вмер Він за нас,</a:t>
-            </a:r>
-            <a:endParaRPr lang="en-US" sz="5100" dirty="0"/>
+              <a:t>В моїм серці є мелодія…</a:t>
+            </a:r>
+            <a:endParaRPr lang="en-US" sz="5200" dirty="0"/>
           </a:p>
           <a:p>
             <a:pPr algn="ctr" indent="0" marL="0">
               <a:buNone/>
             </a:pPr>
             <a:r>
-              <a:rPr lang="en-US" sz="5100" b="1" dirty="0">
+              <a:rPr lang="en-US" sz="5200" b="1" i="1" dirty="0">
                 <a:solidFill>
                   <a:srgbClr val="FFFFFF"/>
                 </a:solidFill>
@@ -1774,16 +1863,16 @@
                 <a:ea typeface="Arial" pitchFamily="34" charset="-122"/>
                 <a:cs typeface="Arial" pitchFamily="34" charset="-120"/>
               </a:rPr>
-              <a:t>Дала мені вже життя.</a:t>
-            </a:r>
-            <a:endParaRPr lang="en-US" sz="5100" dirty="0"/>
+              <a:t>Яка чудова є!</a:t>
+            </a:r>
+            <a:endParaRPr lang="en-US" sz="5200" dirty="0"/>
           </a:p>
           <a:p>
             <a:pPr algn="ctr" indent="0" marL="0">
               <a:buNone/>
             </a:pPr>
             <a:r>
-              <a:rPr lang="en-US" sz="5100" b="1" dirty="0">
+              <a:rPr lang="en-US" sz="5200" b="1" i="1" dirty="0">
                 <a:solidFill>
                   <a:srgbClr val="FFFFFF"/>
                 </a:solidFill>
@@ -1791,16 +1880,16 @@
                 <a:ea typeface="Arial" pitchFamily="34" charset="-122"/>
                 <a:cs typeface="Arial" pitchFamily="34" charset="-120"/>
               </a:rPr>
-              <a:t>І в серце вселила мелодію…</a:t>
-            </a:r>
-            <a:endParaRPr lang="en-US" sz="5100" dirty="0"/>
+              <a:t>В моїм серці є мелодія –</a:t>
+            </a:r>
+            <a:endParaRPr lang="en-US" sz="5200" dirty="0"/>
           </a:p>
           <a:p>
             <a:pPr algn="ctr" indent="0" marL="0">
               <a:buNone/>
             </a:pPr>
             <a:r>
-              <a:rPr lang="en-US" sz="5100" b="1" dirty="0">
+              <a:rPr lang="en-US" sz="5200" b="1" i="1" dirty="0">
                 <a:solidFill>
                   <a:srgbClr val="FFFFFF"/>
                 </a:solidFill>
@@ -1808,9 +1897,9 @@
                 <a:ea typeface="Arial" pitchFamily="34" charset="-122"/>
                 <a:cs typeface="Arial" pitchFamily="34" charset="-120"/>
               </a:rPr>
-              <a:t>Радію тепер вже я.</a:t>
-            </a:r>
-            <a:endParaRPr lang="en-US" sz="5100" dirty="0"/>
+              <a:t>То є мелодія любві!</a:t>
+            </a:r>
+            <a:endParaRPr lang="en-US" sz="5200" dirty="0"/>
           </a:p>
         </p:txBody>
       </p:sp>
@@ -1871,7 +1960,7 @@
               <a:buNone/>
             </a:pPr>
             <a:r>
-              <a:rPr lang="en-US" sz="5200" b="1" dirty="0">
+              <a:rPr lang="en-US" sz="5100" b="1" dirty="0">
                 <a:solidFill>
                   <a:srgbClr val="FFFFFF"/>
                 </a:solidFill>
@@ -1879,16 +1968,16 @@
                 <a:ea typeface="Arial" pitchFamily="34" charset="-122"/>
                 <a:cs typeface="Arial" pitchFamily="34" charset="-120"/>
               </a:rPr>
-              <a:t>Буду співати Спасові я,</a:t>
-            </a:r>
-            <a:endParaRPr lang="en-US" sz="5200" dirty="0"/>
+              <a:t>Любов Христа, що вмер Він за нас,</a:t>
+            </a:r>
+            <a:endParaRPr lang="en-US" sz="5100" dirty="0"/>
           </a:p>
           <a:p>
             <a:pPr algn="ctr" indent="0" marL="0">
               <a:buNone/>
             </a:pPr>
             <a:r>
-              <a:rPr lang="en-US" sz="5200" b="1" dirty="0">
+              <a:rPr lang="en-US" sz="5100" b="1" dirty="0">
                 <a:solidFill>
                   <a:srgbClr val="FFFFFF"/>
                 </a:solidFill>
@@ -1896,16 +1985,16 @@
                 <a:ea typeface="Arial" pitchFamily="34" charset="-122"/>
                 <a:cs typeface="Arial" pitchFamily="34" charset="-120"/>
               </a:rPr>
-              <a:t>Коли там зійдемося всі.</a:t>
-            </a:r>
-            <a:endParaRPr lang="en-US" sz="5200" dirty="0"/>
+              <a:t>Дала мені вже життя.</a:t>
+            </a:r>
+            <a:endParaRPr lang="en-US" sz="5100" dirty="0"/>
           </a:p>
           <a:p>
             <a:pPr algn="ctr" indent="0" marL="0">
               <a:buNone/>
             </a:pPr>
             <a:r>
-              <a:rPr lang="en-US" sz="5200" b="1" dirty="0">
+              <a:rPr lang="en-US" sz="5100" b="1" dirty="0">
                 <a:solidFill>
                   <a:srgbClr val="FFFFFF"/>
                 </a:solidFill>
@@ -1913,16 +2002,16 @@
                 <a:ea typeface="Arial" pitchFamily="34" charset="-122"/>
                 <a:cs typeface="Arial" pitchFamily="34" charset="-120"/>
               </a:rPr>
-              <a:t>О, як буде там мені радісно,</a:t>
-            </a:r>
-            <a:endParaRPr lang="en-US" sz="5200" dirty="0"/>
+              <a:t>І в серце вселила мелодію…</a:t>
+            </a:r>
+            <a:endParaRPr lang="en-US" sz="5100" dirty="0"/>
           </a:p>
           <a:p>
             <a:pPr algn="ctr" indent="0" marL="0">
               <a:buNone/>
             </a:pPr>
             <a:r>
-              <a:rPr lang="en-US" sz="5200" b="1" dirty="0">
+              <a:rPr lang="en-US" sz="5100" b="1" dirty="0">
                 <a:solidFill>
                   <a:srgbClr val="FFFFFF"/>
                 </a:solidFill>
@@ -1930,9 +2019,9 @@
                 <a:ea typeface="Arial" pitchFamily="34" charset="-122"/>
                 <a:cs typeface="Arial" pitchFamily="34" charset="-120"/>
               </a:rPr>
-              <a:t>Коли зустріну своїх!</a:t>
-            </a:r>
-            <a:endParaRPr lang="en-US" sz="5200" dirty="0"/>
+              <a:t>Радію тепер вже я.</a:t>
+            </a:r>
+            <a:endParaRPr lang="en-US" sz="5100" dirty="0"/>
           </a:p>
         </p:txBody>
       </p:sp>
@@ -1993,6 +2082,128 @@
               <a:buNone/>
             </a:pPr>
             <a:r>
+              <a:rPr lang="en-US" sz="5200" b="1" dirty="0">
+                <a:solidFill>
+                  <a:srgbClr val="FFFFFF"/>
+                </a:solidFill>
+                <a:latin typeface="Arial" pitchFamily="34" charset="0"/>
+                <a:ea typeface="Arial" pitchFamily="34" charset="-122"/>
+                <a:cs typeface="Arial" pitchFamily="34" charset="-120"/>
+              </a:rPr>
+              <a:t>Буду співати Спасові я,</a:t>
+            </a:r>
+            <a:endParaRPr lang="en-US" sz="5200" dirty="0"/>
+          </a:p>
+          <a:p>
+            <a:pPr algn="ctr" indent="0" marL="0">
+              <a:buNone/>
+            </a:pPr>
+            <a:r>
+              <a:rPr lang="en-US" sz="5200" b="1" dirty="0">
+                <a:solidFill>
+                  <a:srgbClr val="FFFFFF"/>
+                </a:solidFill>
+                <a:latin typeface="Arial" pitchFamily="34" charset="0"/>
+                <a:ea typeface="Arial" pitchFamily="34" charset="-122"/>
+                <a:cs typeface="Arial" pitchFamily="34" charset="-120"/>
+              </a:rPr>
+              <a:t>Коли там зійдемося всі.</a:t>
+            </a:r>
+            <a:endParaRPr lang="en-US" sz="5200" dirty="0"/>
+          </a:p>
+          <a:p>
+            <a:pPr algn="ctr" indent="0" marL="0">
+              <a:buNone/>
+            </a:pPr>
+            <a:r>
+              <a:rPr lang="en-US" sz="5200" b="1" dirty="0">
+                <a:solidFill>
+                  <a:srgbClr val="FFFFFF"/>
+                </a:solidFill>
+                <a:latin typeface="Arial" pitchFamily="34" charset="0"/>
+                <a:ea typeface="Arial" pitchFamily="34" charset="-122"/>
+                <a:cs typeface="Arial" pitchFamily="34" charset="-120"/>
+              </a:rPr>
+              <a:t>О, як буде там мені радісно,</a:t>
+            </a:r>
+            <a:endParaRPr lang="en-US" sz="5200" dirty="0"/>
+          </a:p>
+          <a:p>
+            <a:pPr algn="ctr" indent="0" marL="0">
+              <a:buNone/>
+            </a:pPr>
+            <a:r>
+              <a:rPr lang="en-US" sz="5200" b="1" dirty="0">
+                <a:solidFill>
+                  <a:srgbClr val="FFFFFF"/>
+                </a:solidFill>
+                <a:latin typeface="Arial" pitchFamily="34" charset="0"/>
+                <a:ea typeface="Arial" pitchFamily="34" charset="-122"/>
+                <a:cs typeface="Arial" pitchFamily="34" charset="-120"/>
+              </a:rPr>
+              <a:t>Коли зустріну своїх!</a:t>
+            </a:r>
+            <a:endParaRPr lang="en-US" sz="5200" dirty="0"/>
+          </a:p>
+        </p:txBody>
+      </p:sp>
+    </p:spTree>
+  </p:cSld>
+  <p:clrMapOvr>
+    <a:masterClrMapping/>
+  </p:clrMapOvr>
+</p:sld>
+</file>
+
+<file path=ppt/slides/slide7.xml><?xml version="1.0" encoding="utf-8"?>
+<p:sld xmlns:a="http://schemas.openxmlformats.org/drawingml/2006/main" xmlns:r="http://schemas.openxmlformats.org/officeDocument/2006/relationships" xmlns:p="http://schemas.openxmlformats.org/presentationml/2006/main">
+  <p:cSld name="Slide 7">
+    <p:bg>
+      <p:bgPr>
+        <a:solidFill>
+          <a:srgbClr val="000000"/>
+        </a:solidFill>
+      </p:bgPr>
+    </p:bg>
+    <p:spTree>
+      <p:nvGrpSpPr>
+        <p:cNvPr id="1" name=""/>
+        <p:cNvGrpSpPr/>
+        <p:nvPr/>
+      </p:nvGrpSpPr>
+      <p:grpSpPr>
+        <a:xfrm>
+          <a:off x="0" y="0"/>
+          <a:ext cx="0" cy="0"/>
+          <a:chOff x="0" y="0"/>
+          <a:chExt cx="0" cy="0"/>
+        </a:xfrm>
+      </p:grpSpPr>
+      <p:sp>
+        <p:nvSpPr>
+          <p:cNvPr id="2" name="Text 0"/>
+          <p:cNvSpPr txBox="1"/>
+          <p:nvPr/>
+        </p:nvSpPr>
+        <p:spPr>
+          <a:xfrm>
+            <a:off x="292608" y="457200"/>
+            <a:ext cx="11612880" cy="5943600"/>
+          </a:xfrm>
+          <a:prstGeom prst="rect">
+            <a:avLst/>
+          </a:prstGeom>
+          <a:noFill/>
+          <a:ln/>
+        </p:spPr>
+        <p:txBody>
+          <a:bodyPr wrap="square" lIns="0" tIns="0" rIns="0" bIns="0" rtlCol="0" anchor="ctr"/>
+          <a:lstStyle/>
+          <a:p>
+            <a:pPr algn="ctr" indent="0" marL="0">
+              <a:buNone/>
+            </a:pPr>
+            <a:r>
               <a:rPr lang="en-US" sz="5200" b="1" i="1" dirty="0">
                 <a:solidFill>
                   <a:srgbClr val="FFFFFF"/>
@@ -2105,9 +2316,9 @@
 </p:sld>
 </file>
 
-<file path=ppt/slides/slide7.xml><?xml version="1.0" encoding="utf-8"?>
+<file path=ppt/slides/slide8.xml><?xml version="1.0" encoding="utf-8"?>
 <p:sld xmlns:a="http://schemas.openxmlformats.org/drawingml/2006/main" xmlns:r="http://schemas.openxmlformats.org/officeDocument/2006/relationships" xmlns:p="http://schemas.openxmlformats.org/presentationml/2006/main">
-  <p:cSld name="Slide 7">
+  <p:cSld name="Slide 8">
     <p:bg>
       <p:bgPr>
         <a:solidFill>

</xml_diff>